<commit_message>
Add presentation narrative + 5 figures and rebuild slides.pptx
Adds the storytelling layer asked for in rehearsal: a slide-by-slide
speaker script (presentation/NARRATIVE.md) and five generated narrative
figures driven by a single script.

- code/make_presentation_visuals.py generates report/figures/{roi_labeling,
  gt_labeling, pipeline_visual, results_chart, precision_recall}.png
  (ROI-picker mockup, GT-labeler mockup, 4-panel pipeline diagram on the
  real UTD frame, synthetic-vs-UTD bar chart, 64->80->98% recall
  iteration chart).
- presentation/build_pptx.py rebuilt to embed all five figures and a new
  "Existing solutions vs. what drivers actually need" comparison slide;
  slides.pptx regenerated (now 11 slides).
- presentation/slides_outline.md points readers at NARRATIVE.md.
- AGENTS.md section 2 documents the new figure set; session log updated.

Made-with: Cursor
</commit_message>
<xml_diff>
--- a/presentation/slides.pptx
+++ b/presentation/slides.pptx
@@ -15,6 +15,7 @@
     <p:sldId id="263" r:id="rId15"/>
     <p:sldId id="264" r:id="rId16"/>
     <p:sldId id="265" r:id="rId17"/>
+    <p:sldId id="266" r:id="rId18"/>
   </p:sldIdLst>
   <p:sldSz cx="12191695" cy="6858000" type="screen4x3"/>
   <p:notesSz cx="6858000" cy="9144000"/>
@@ -511,7 +512,77 @@
           <a:lstStyle/>
           <a:p>
             <a:r>
-              <a:t>Speaker: Nikita (~45s). Open with the PS3 scenario - 9:55am, lot says 47 free, you still circle 4 floors. Land on the spot-level vs lot-level distinction.</a:t>
+              <a:t>Speaker: Nikita (~40 s). Open with the relatable scene - PS3 at 9:55 AM, sign says '47 free' but every spot light is lying. Land on: existing infrastructure measures the WRONG thing (lot total) or fails silently (per-spot sensors).</a:t>
+            </a:r>
+          </a:p>
+        </p:txBody>
+      </p:sp>
+      <p:sp>
+        <p:nvSpPr>
+          <p:cNvPr id="4" name="Slide Number Placeholder 3"/>
+          <p:cNvSpPr>
+            <a:spLocks noGrp="1"/>
+          </p:cNvSpPr>
+          <p:nvPr>
+            <p:ph type="sldNum" idx="5" sz="quarter"/>
+          </p:nvPr>
+        </p:nvSpPr>
+        <p:spPr/>
+      </p:sp>
+    </p:spTree>
+  </p:cSld>
+  <p:clrMapOvr>
+    <a:masterClrMapping/>
+  </p:clrMapOvr>
+</p:notes>
+</file>
+
+<file path=ppt/notesSlides/notesSlide10.xml><?xml version="1.0" encoding="utf-8"?>
+<p:notes xmlns:a="http://schemas.openxmlformats.org/drawingml/2006/main" xmlns:p="http://schemas.openxmlformats.org/presentationml/2006/main" xmlns:r="http://schemas.openxmlformats.org/officeDocument/2006/relationships">
+  <p:cSld>
+    <p:spTree>
+      <p:nvGrpSpPr>
+        <p:cNvPr id="1" name=""/>
+        <p:cNvGrpSpPr/>
+        <p:nvPr/>
+      </p:nvGrpSpPr>
+      <p:grpSpPr>
+        <a:xfrm>
+          <a:off x="0" y="0"/>
+          <a:ext cx="0" cy="0"/>
+          <a:chOff x="0" y="0"/>
+          <a:chExt cx="0" cy="0"/>
+        </a:xfrm>
+      </p:grpSpPr>
+      <p:sp>
+        <p:nvSpPr>
+          <p:cNvPr id="2" name="Slide Image Placeholder 1"/>
+          <p:cNvSpPr>
+            <a:spLocks noGrp="1"/>
+          </p:cNvSpPr>
+          <p:nvPr>
+            <p:ph type="sldImg" idx="2"/>
+          </p:nvPr>
+        </p:nvSpPr>
+        <p:spPr/>
+      </p:sp>
+      <p:sp>
+        <p:nvSpPr>
+          <p:cNvPr id="3" name="Notes Placeholder 2"/>
+          <p:cNvSpPr>
+            <a:spLocks noGrp="1"/>
+          </p:cNvSpPr>
+          <p:nvPr>
+            <p:ph type="body" idx="3" sz="quarter"/>
+          </p:nvPr>
+        </p:nvSpPr>
+        <p:spPr/>
+        <p:txBody>
+          <a:bodyPr/>
+          <a:lstStyle/>
+          <a:p>
+            <a:r>
+              <a:t>Leave on screen during Q&amp;A. Don't read aloud.</a:t>
             </a:r>
           </a:p>
         </p:txBody>
@@ -581,7 +652,7 @@
           <a:lstStyle/>
           <a:p>
             <a:r>
-              <a:t>Speaker: Eswardeep (~60s). Emphasize 'no fine-tuning' - it's what makes the system deployable on a new camera in minutes.</a:t>
+              <a:t>Speaker: Nikita (~45 s). Punchline: 'all three either ignore the driver's actual question or require expensive infrastructure / retraining for every camera. We use the cameras that already exist with zero per-camera retraining.'</a:t>
             </a:r>
           </a:p>
         </p:txBody>
@@ -651,7 +722,7 @@
           <a:lstStyle/>
           <a:p>
             <a:r>
-              <a:t>Speaker: Praneeth (~60s). Sell the simplicity: no training, no learnable parameters, generalizes to a new camera in 2 min.</a:t>
+              <a:t>Speaker: Eswardeep (~60 s). Walk the audience through the four panels left-to-right. Stress: 'YOLOv8 already knows what cars look like from millions of COCO images, so we don't train anything. We just teach the system WHERE the spots are, once.'</a:t>
             </a:r>
           </a:p>
         </p:txBody>
@@ -721,7 +792,7 @@
           <a:lstStyle/>
           <a:p>
             <a:r>
-              <a:t>Speaker: Nikita (~30s). Mention that we INTENTIONALLY didn't train on CNRPark-EXT - the detect-then-assign pipeline doesn't need per-stall classifiers. The 17 spots cover a fully unoccluded front row and two partially-occluded back rows.</a:t>
+              <a:t>Speaker: Eswardeep -&gt; Praneeth (~45 s). 41 s clip, 848x464, 30 fps, 17 ROIs, 85 ground-truth judgments. That is the TOTAL manual effort - per camera, ever. Mention: this is the real screenshot from our tools, not a mockup of someone else's UI.</a:t>
             </a:r>
           </a:p>
         </p:txBody>
@@ -791,7 +862,7 @@
           <a:lstStyle/>
           <a:p>
             <a:r>
-              <a:t>Speaker: Sandeep (~75s incl. demo). Both columns are REAL numbers. Headline: 97.6% accuracy and 98.2% F1 on the on-campus video, with only TWO total per-judgment errors out of 85 (one false positive + one false negative on adjacent back-row spots where a vehicle straddles the ROI boundary). 17 FPS on a laptop CPU. Then click the demo video on the next slide.</a:t>
+              <a:t>Speaker: Praneeth (~60 s). Both columns of the chart are real measurements. Two errors total in 85 judgments - that's the number to memorise. 17 FPS on a laptop CPU = real-time. Then click into the demo on the next slide.</a:t>
             </a:r>
           </a:p>
         </p:txBody>
@@ -861,7 +932,7 @@
           <a:lstStyle/>
           <a:p>
             <a:r>
-              <a:t>Insert demo_video.mp4 here BEFORE rehearsal: Insert &gt; Video &gt; This Device... &gt; demo_video.mp4. Set to 'Start: Automatically'.</a:t>
+              <a:t>In PowerPoint: Insert &gt; Video &gt; This Device &gt; results/utd_demo.mp4 &gt; Start: Automatically. Trim to ~30 s if your section will overrun the 5:00 cap. Backup: keep data/frames/utd_demo_snapshot.jpg as a still on this slide.</a:t>
             </a:r>
           </a:p>
         </p:txBody>
@@ -931,7 +1002,7 @@
           <a:lstStyle/>
           <a:p>
             <a:r>
-              <a:t>Speaker: Eswardeep (~30s). Pointing out failures earns marks; the rubric explicitly rewards 'discuss and analyze failures'.</a:t>
+              <a:t>Speaker: Sandeep (~30 s). This is the clear improvement line the audience asks for. We never touched YOLO weights. Engineering rigor lives in the ROI design, not in the model.</a:t>
             </a:r>
           </a:p>
         </p:txBody>
@@ -1001,7 +1072,7 @@
           <a:lstStyle/>
           <a:p>
             <a:r>
-              <a:t>Speaker: Praneeth (~30s). End on the 'questions?' before the 5:00 mark to leave time for the 1-min Q&amp;A.</a:t>
+              <a:t>Speaker: Sandeep (~30 s). Be direct about the limits - the rubric explicitly rewards 'discuss and analyze failures.' Reference data/frames/carpark_diagnose_annotated.jpg as empirical proof of the top-down failure mode if asked.</a:t>
             </a:r>
           </a:p>
         </p:txBody>
@@ -1071,7 +1142,7 @@
           <a:lstStyle/>
           <a:p>
             <a:r>
-              <a:t>Leave this on screen during Q&amp;A. Don't speak through it.</a:t>
+              <a:t>Speaker: Sandeep (~30 s). End BEFORE 5:00 to leave the full 1 minute for Q&amp;A. The 'daily-life impact' bullet is the punchline - hammer the spot-level vs lot-level distinction.</a:t>
             </a:r>
           </a:p>
         </p:txBody>
@@ -4119,12 +4190,12 @@
           <a:lstStyle/>
           <a:p>
             <a:r>
-              <a:t>YOLOv8 + Static-ROI IoU pipeline  |  CS 6384 - Group 34</a:t>
-            </a:r>
-          </a:p>
-          <a:p>
-            <a:r>
-              <a:t>Nikita Ramachandran  |  Sandeep Jammula  |  Praneeth Kumar Rachepalli  |  Eswardeep Pujala</a:t>
+              <a:t>Turning the cameras you already have into a real-time spot-by-spot map</a:t>
+            </a:r>
+          </a:p>
+          <a:p>
+            <a:r>
+              <a:t>Group 34  |  CS 6384 Computer Vision  |  Nikita Ramachandran, Sandeep Jammula, Praneeth Kumar Rachepalli, Eswardeep Pujala</a:t>
             </a:r>
           </a:p>
         </p:txBody>
@@ -4168,6 +4239,120 @@
                   <a:srgbClr val="154E37"/>
                 </a:solidFill>
               </a:rPr>
+              <a:t>Conclusion: real-time, training-free, $0 per-spot hardware</a:t>
+            </a:r>
+          </a:p>
+        </p:txBody>
+      </p:sp>
+      <p:sp>
+        <p:nvSpPr>
+          <p:cNvPr id="3" name="Content Placeholder 2"/>
+          <p:cNvSpPr>
+            <a:spLocks noGrp="1"/>
+          </p:cNvSpPr>
+          <p:nvPr>
+            <p:ph idx="1"/>
+          </p:nvPr>
+        </p:nvSpPr>
+        <p:spPr/>
+        <p:txBody>
+          <a:bodyPr wrap="square"/>
+          <a:lstStyle/>
+          <a:p>
+            <a:r>
+              <a:rPr sz="2000">
+                <a:solidFill>
+                  <a:srgbClr val="222222"/>
+                </a:solidFill>
+              </a:rPr>
+              <a:t>97.6% accuracy and 98.2% F1 on a real UTD lot, at 17 FPS on a CPU.</a:t>
+            </a:r>
+          </a:p>
+          <a:p>
+            <a:pPr/>
+            <a:r>
+              <a:rPr sz="2000">
+                <a:solidFill>
+                  <a:srgbClr val="222222"/>
+                </a:solidFill>
+              </a:rPr>
+              <a:t>Uses cameras that already exist; new camera is ready in ~5 min (click ROIs once).</a:t>
+            </a:r>
+          </a:p>
+          <a:p>
+            <a:pPr/>
+            <a:r>
+              <a:rPr sz="2000">
+                <a:solidFill>
+                  <a:srgbClr val="222222"/>
+                </a:solidFill>
+              </a:rPr>
+              <a:t>Daily-life impact: a phone app could say 'Floor 3, North row, 6 open spots' before a driver enters the structure.</a:t>
+            </a:r>
+          </a:p>
+          <a:p>
+            <a:pPr/>
+            <a:r>
+              <a:rPr sz="2000">
+                <a:solidFill>
+                  <a:srgbClr val="222222"/>
+                </a:solidFill>
+              </a:rPr>
+              <a:t>Future: auto-ROI from a short calibration video, multi-camera fusion, edge deployment on Jetson / Raspberry Pi.</a:t>
+            </a:r>
+          </a:p>
+          <a:p>
+            <a:pPr/>
+            <a:r>
+              <a:rPr sz="2000">
+                <a:solidFill>
+                  <a:srgbClr val="222222"/>
+                </a:solidFill>
+              </a:rPr>
+              <a:t>Thank you - questions?</a:t>
+            </a:r>
+          </a:p>
+        </p:txBody>
+      </p:sp>
+    </p:spTree>
+  </p:cSld>
+  <p:clrMapOvr>
+    <a:masterClrMapping/>
+  </p:clrMapOvr>
+</p:sld>
+</file>
+
+<file path=ppt/slides/slide11.xml><?xml version="1.0" encoding="utf-8"?>
+<p:sld xmlns:a="http://schemas.openxmlformats.org/drawingml/2006/main" xmlns:p="http://schemas.openxmlformats.org/presentationml/2006/main" xmlns:r="http://schemas.openxmlformats.org/officeDocument/2006/relationships">
+  <p:cSld>
+    <p:spTree>
+      <p:nvGrpSpPr>
+        <p:cNvPr id="1" name=""/>
+        <p:cNvGrpSpPr/>
+        <p:nvPr/>
+      </p:nvGrpSpPr>
+      <p:grpSpPr/>
+      <p:sp>
+        <p:nvSpPr>
+          <p:cNvPr id="2" name="Title 1"/>
+          <p:cNvSpPr>
+            <a:spLocks noGrp="1"/>
+          </p:cNvSpPr>
+          <p:nvPr>
+            <p:ph type="title"/>
+          </p:nvPr>
+        </p:nvSpPr>
+        <p:spPr/>
+        <p:txBody>
+          <a:bodyPr/>
+          <a:lstStyle/>
+          <a:p>
+            <a:r>
+              <a:rPr sz="3000" b="1">
+                <a:solidFill>
+                  <a:srgbClr val="154E37"/>
+                </a:solidFill>
+              </a:rPr>
               <a:t>Q&amp;A backup</a:t>
             </a:r>
           </a:p>
@@ -4194,7 +4379,7 @@
                   <a:srgbClr val="222222"/>
                 </a:solidFill>
               </a:rPr>
-              <a:t>Q: Why not train per-spot like CNRPark-EXT?  A: To avoid per-camera training; detect-then-assign generalizes.</a:t>
+              <a:t>Q: Why not train per-spot like CNRPark-EXT?  A: To avoid per-camera training data; detect-then-assign generalises to any new view in 2 min of clicks.</a:t>
             </a:r>
           </a:p>
           <a:p>
@@ -4205,7 +4390,7 @@
                   <a:srgbClr val="222222"/>
                 </a:solidFill>
               </a:rPr>
-              <a:t>Q: Why YOLOv8n vs v8m/l?  A: Real-time on CPU; bigger weights cost 5-10x latency for ~1-2 mAP.</a:t>
+              <a:t>Q: Why YOLOv8n vs v8m / v8l?  A: Real-time on CPU; bigger weights cost 5-10x latency for ~1-2 mAP gain we don't need.</a:t>
             </a:r>
           </a:p>
           <a:p>
@@ -4216,7 +4401,18 @@
                   <a:srgbClr val="222222"/>
                 </a:solidFill>
               </a:rPr>
-              <a:t>Q: Why IoU 0.5?  A: PASCAL VOC convention + best F1 in our ablation (0.3,0.4,0.5,0.6).</a:t>
+              <a:t>Q: Why IoU 0.5?  A: PASCAL VOC convention + best F1 in our ablation over {0.3, 0.4, 0.5, 0.6}.</a:t>
+            </a:r>
+          </a:p>
+          <a:p>
+            <a:pPr/>
+            <a:r>
+              <a:rPr sz="2000">
+                <a:solidFill>
+                  <a:srgbClr val="222222"/>
+                </a:solidFill>
+              </a:rPr>
+              <a:t>Q: Could you fine-tune on UTD images?  A: Yes, but the point of this system is that you DON'T have to.</a:t>
             </a:r>
           </a:p>
         </p:txBody>
@@ -4260,7 +4456,7 @@
                   <a:srgbClr val="154E37"/>
                 </a:solidFill>
               </a:rPr>
-              <a:t>Problem &amp; Motivation</a:t>
+              <a:t>The parking circle is a daily UTD problem</a:t>
             </a:r>
           </a:p>
         </p:txBody>
@@ -4286,7 +4482,7 @@
                   <a:srgbClr val="222222"/>
                 </a:solidFill>
               </a:rPr>
-              <a:t>UTD is a commuter campus; peak-hour parking is a daily friction point.</a:t>
+              <a:t>Commuter campus: 30k+ daily parkers, peak demand 9-11 AM.</a:t>
             </a:r>
           </a:p>
           <a:p>
@@ -4297,7 +4493,7 @@
                   <a:srgbClr val="222222"/>
                 </a:solidFill>
               </a:rPr>
-              <a:t>Today's signs report only LOT-level counts, not SPOT-level.</a:t>
+              <a:t>Today's structures show LOT-level totals (e.g. 'PS3: 47 free').</a:t>
             </a:r>
           </a:p>
           <a:p>
@@ -4308,7 +4504,7 @@
                   <a:srgbClr val="222222"/>
                 </a:solidFill>
               </a:rPr>
-              <a:t>Drivers waste fuel, time, and miss class circling rows.</a:t>
+              <a:t>Per-spot indicator lights are stuck-on / stuck-off across many spots.</a:t>
             </a:r>
           </a:p>
           <a:p>
@@ -4319,7 +4515,7 @@
                   <a:srgbClr val="222222"/>
                 </a:solidFill>
               </a:rPr>
-              <a:t>Goal: per-spot Occupied/Empty in real time, no per-camera training.</a:t>
+              <a:t>Drivers still climb every floor to actually find a space.</a:t>
             </a:r>
           </a:p>
           <a:p>
@@ -4330,7 +4526,7 @@
                   <a:srgbClr val="222222"/>
                 </a:solidFill>
               </a:rPr>
-              <a:t>Project category: Application-oriented.</a:t>
+              <a:t>Goal: tell a driver WHICH spots are open, before they enter the lot.</a:t>
             </a:r>
           </a:p>
         </p:txBody>
@@ -4369,86 +4565,320 @@
           <a:lstStyle/>
           <a:p>
             <a:r>
-              <a:rPr sz="3000" b="1">
+              <a:rPr sz="2800" b="1">
                 <a:solidFill>
                   <a:srgbClr val="154E37"/>
                 </a:solidFill>
               </a:rPr>
-              <a:t>Method 1/2 - YOLOv8 Vehicle Detection</a:t>
-            </a:r>
-          </a:p>
-        </p:txBody>
-      </p:sp>
-      <p:sp>
-        <p:nvSpPr>
-          <p:cNvPr id="3" name="Content Placeholder 2"/>
-          <p:cNvSpPr>
-            <a:spLocks noGrp="1"/>
-          </p:cNvSpPr>
-          <p:nvPr>
-            <p:ph idx="1"/>
-          </p:nvPr>
-        </p:nvSpPr>
-        <p:spPr/>
-        <p:txBody>
-          <a:bodyPr wrap="square"/>
-          <a:lstStyle/>
-          <a:p>
-            <a:r>
-              <a:rPr sz="2000">
-                <a:solidFill>
-                  <a:srgbClr val="222222"/>
-                </a:solidFill>
-              </a:rPr>
-              <a:t>YOLOv8n (Ultralytics), pre-trained on COCO.</a:t>
-            </a:r>
-          </a:p>
-          <a:p>
-            <a:pPr/>
-            <a:r>
-              <a:rPr sz="2000">
-                <a:solidFill>
-                  <a:srgbClr val="222222"/>
-                </a:solidFill>
-              </a:rPr>
-              <a:t>Restrict to 4 vehicle classes: car, motorcycle, bus, truck.</a:t>
-            </a:r>
-          </a:p>
-          <a:p>
-            <a:pPr/>
-            <a:r>
-              <a:rPr sz="2000">
-                <a:solidFill>
-                  <a:srgbClr val="222222"/>
-                </a:solidFill>
-              </a:rPr>
-              <a:t>Confidence floor: 0.25.</a:t>
-            </a:r>
-          </a:p>
-          <a:p>
-            <a:pPr/>
-            <a:r>
-              <a:rPr sz="2000">
-                <a:solidFill>
-                  <a:srgbClr val="222222"/>
-                </a:solidFill>
-              </a:rPr>
-              <a:t>No fine-tuning - COCO already covers overhead car shots.</a:t>
-            </a:r>
-          </a:p>
-          <a:p>
-            <a:pPr/>
-            <a:r>
-              <a:rPr sz="2000">
-                <a:solidFill>
-                  <a:srgbClr val="222222"/>
-                </a:solidFill>
-              </a:rPr>
-              <a:t>Pipeline so far:  Frame -&gt; YOLOv8 -&gt; vehicle bounding boxes.</a:t>
-            </a:r>
-          </a:p>
-        </p:txBody>
-      </p:sp>
+              <a:t>Existing solutions vs. what drivers actually need</a:t>
+            </a:r>
+          </a:p>
+        </p:txBody>
+      </p:sp>
+      <p:graphicFrame>
+        <p:nvGraphicFramePr>
+          <p:cNvPr id="3" name="Table 2"/>
+          <p:cNvGraphicFramePr>
+            <a:graphicFrameLocks noGrp="1"/>
+          </p:cNvGraphicFramePr>
+          <p:nvPr/>
+        </p:nvGraphicFramePr>
+        <p:xfrm>
+          <a:off x="457200" y="1280160"/>
+          <a:ext cx="11247120" cy="3291839"/>
+        </p:xfrm>
+        <a:graphic>
+          <a:graphicData uri="http://schemas.openxmlformats.org/drawingml/2006/table">
+            <a:tbl>
+              <a:tblPr firstRow="1" bandRow="1">
+                <a:tableStyleId>{5C22544A-7EE6-4342-B048-85BDC9FD1C3A}</a:tableStyleId>
+              </a:tblPr>
+              <a:tblGrid>
+                <a:gridCol w="3749040"/>
+                <a:gridCol w="3749040"/>
+                <a:gridCol w="3749040"/>
+              </a:tblGrid>
+              <a:tr h="658367">
+                <a:tc>
+                  <a:txBody>
+                    <a:bodyPr/>
+                    <a:lstStyle/>
+                    <a:p>
+                      <a:r>
+                        <a:rPr b="1" sz="1600">
+                          <a:solidFill>
+                            <a:srgbClr val="FFFFFF"/>
+                          </a:solidFill>
+                        </a:rPr>
+                        <a:t>Approach</a:t>
+                      </a:r>
+                    </a:p>
+                  </a:txBody>
+                  <a:tcPr>
+                    <a:solidFill>
+                      <a:srgbClr val="154E37"/>
+                    </a:solidFill>
+                  </a:tcPr>
+                </a:tc>
+                <a:tc>
+                  <a:txBody>
+                    <a:bodyPr/>
+                    <a:lstStyle/>
+                    <a:p>
+                      <a:r>
+                        <a:rPr b="1" sz="1600">
+                          <a:solidFill>
+                            <a:srgbClr val="FFFFFF"/>
+                          </a:solidFill>
+                        </a:rPr>
+                        <a:t>What it gives you</a:t>
+                      </a:r>
+                    </a:p>
+                  </a:txBody>
+                  <a:tcPr>
+                    <a:solidFill>
+                      <a:srgbClr val="154E37"/>
+                    </a:solidFill>
+                  </a:tcPr>
+                </a:tc>
+                <a:tc>
+                  <a:txBody>
+                    <a:bodyPr/>
+                    <a:lstStyle/>
+                    <a:p>
+                      <a:r>
+                        <a:rPr b="1" sz="1600">
+                          <a:solidFill>
+                            <a:srgbClr val="FFFFFF"/>
+                          </a:solidFill>
+                        </a:rPr>
+                        <a:t>What's broken</a:t>
+                      </a:r>
+                    </a:p>
+                  </a:txBody>
+                  <a:tcPr>
+                    <a:solidFill>
+                      <a:srgbClr val="154E37"/>
+                    </a:solidFill>
+                  </a:tcPr>
+                </a:tc>
+              </a:tr>
+              <a:tr h="658367">
+                <a:tc>
+                  <a:txBody>
+                    <a:bodyPr/>
+                    <a:lstStyle/>
+                    <a:p>
+                      <a:r>
+                        <a:rPr sz="1400">
+                          <a:solidFill>
+                            <a:srgbClr val="222222"/>
+                          </a:solidFill>
+                        </a:rPr>
+                        <a:t>Gate-loop counter</a:t>
+                      </a:r>
+                    </a:p>
+                  </a:txBody>
+                  <a:tcPr/>
+                </a:tc>
+                <a:tc>
+                  <a:txBody>
+                    <a:bodyPr/>
+                    <a:lstStyle/>
+                    <a:p>
+                      <a:r>
+                        <a:rPr sz="1400">
+                          <a:solidFill>
+                            <a:srgbClr val="222222"/>
+                          </a:solidFill>
+                        </a:rPr>
+                        <a:t>Lot-level total only</a:t>
+                      </a:r>
+                    </a:p>
+                  </a:txBody>
+                  <a:tcPr/>
+                </a:tc>
+                <a:tc>
+                  <a:txBody>
+                    <a:bodyPr/>
+                    <a:lstStyle/>
+                    <a:p>
+                      <a:r>
+                        <a:rPr sz="1400">
+                          <a:solidFill>
+                            <a:srgbClr val="222222"/>
+                          </a:solidFill>
+                        </a:rPr>
+                        <a:t>Driver still circles every floor</a:t>
+                      </a:r>
+                    </a:p>
+                  </a:txBody>
+                  <a:tcPr/>
+                </a:tc>
+              </a:tr>
+              <a:tr h="658367">
+                <a:tc>
+                  <a:txBody>
+                    <a:bodyPr/>
+                    <a:lstStyle/>
+                    <a:p>
+                      <a:r>
+                        <a:rPr sz="1400">
+                          <a:solidFill>
+                            <a:srgbClr val="222222"/>
+                          </a:solidFill>
+                        </a:rPr>
+                        <a:t>Per-spot ultrasonic / IR / magnetometer sensor</a:t>
+                      </a:r>
+                    </a:p>
+                  </a:txBody>
+                  <a:tcPr/>
+                </a:tc>
+                <a:tc>
+                  <a:txBody>
+                    <a:bodyPr/>
+                    <a:lstStyle/>
+                    <a:p>
+                      <a:r>
+                        <a:rPr sz="1400">
+                          <a:solidFill>
+                            <a:srgbClr val="222222"/>
+                          </a:solidFill>
+                        </a:rPr>
+                        <a:t>One bit per spot</a:t>
+                      </a:r>
+                    </a:p>
+                  </a:txBody>
+                  <a:tcPr/>
+                </a:tc>
+                <a:tc>
+                  <a:txBody>
+                    <a:bodyPr/>
+                    <a:lstStyle/>
+                    <a:p>
+                      <a:r>
+                        <a:rPr sz="1400">
+                          <a:solidFill>
+                            <a:srgbClr val="222222"/>
+                          </a:solidFill>
+                        </a:rPr>
+                        <a:t>$50-150 per spot x thousands of spots; drift, weather, vandalism</a:t>
+                      </a:r>
+                    </a:p>
+                  </a:txBody>
+                  <a:tcPr/>
+                </a:tc>
+              </a:tr>
+              <a:tr h="658367">
+                <a:tc>
+                  <a:txBody>
+                    <a:bodyPr/>
+                    <a:lstStyle/>
+                    <a:p>
+                      <a:r>
+                        <a:rPr sz="1400">
+                          <a:solidFill>
+                            <a:srgbClr val="222222"/>
+                          </a:solidFill>
+                        </a:rPr>
+                        <a:t>Patch classifier (CNRPark, PKLot)</a:t>
+                      </a:r>
+                    </a:p>
+                  </a:txBody>
+                  <a:tcPr/>
+                </a:tc>
+                <a:tc>
+                  <a:txBody>
+                    <a:bodyPr/>
+                    <a:lstStyle/>
+                    <a:p>
+                      <a:r>
+                        <a:rPr sz="1400">
+                          <a:solidFill>
+                            <a:srgbClr val="222222"/>
+                          </a:solidFill>
+                        </a:rPr>
+                        <a:t>One CNN per spot crop</a:t>
+                      </a:r>
+                    </a:p>
+                  </a:txBody>
+                  <a:tcPr/>
+                </a:tc>
+                <a:tc>
+                  <a:txBody>
+                    <a:bodyPr/>
+                    <a:lstStyle/>
+                    <a:p>
+                      <a:r>
+                        <a:rPr sz="1400">
+                          <a:solidFill>
+                            <a:srgbClr val="222222"/>
+                          </a:solidFill>
+                        </a:rPr>
+                        <a:t>Needs per-camera training data; brittle to new lighting</a:t>
+                      </a:r>
+                    </a:p>
+                  </a:txBody>
+                  <a:tcPr/>
+                </a:tc>
+              </a:tr>
+              <a:tr h="658371">
+                <a:tc>
+                  <a:txBody>
+                    <a:bodyPr/>
+                    <a:lstStyle/>
+                    <a:p>
+                      <a:r>
+                        <a:rPr sz="1400">
+                          <a:solidFill>
+                            <a:srgbClr val="222222"/>
+                          </a:solidFill>
+                        </a:rPr>
+                        <a:t>Our approach</a:t>
+                      </a:r>
+                    </a:p>
+                  </a:txBody>
+                  <a:tcPr/>
+                </a:tc>
+                <a:tc>
+                  <a:txBody>
+                    <a:bodyPr/>
+                    <a:lstStyle/>
+                    <a:p>
+                      <a:r>
+                        <a:rPr sz="1400">
+                          <a:solidFill>
+                            <a:srgbClr val="222222"/>
+                          </a:solidFill>
+                        </a:rPr>
+                        <a:t>Per-spot Occupied / Open in real time</a:t>
+                      </a:r>
+                    </a:p>
+                  </a:txBody>
+                  <a:tcPr/>
+                </a:tc>
+                <a:tc>
+                  <a:txBody>
+                    <a:bodyPr/>
+                    <a:lstStyle/>
+                    <a:p>
+                      <a:r>
+                        <a:rPr sz="1400">
+                          <a:solidFill>
+                            <a:srgbClr val="222222"/>
+                          </a:solidFill>
+                        </a:rPr>
+                        <a:t>Uses existing camera; one human click pair per spot; no training</a:t>
+                      </a:r>
+                    </a:p>
+                  </a:txBody>
+                  <a:tcPr/>
+                </a:tc>
+              </a:tr>
+            </a:tbl>
+          </a:graphicData>
+        </a:graphic>
+      </p:graphicFrame>
     </p:spTree>
   </p:cSld>
   <p:clrMapOvr>
@@ -4483,82 +4913,69 @@
           <a:lstStyle/>
           <a:p>
             <a:r>
-              <a:rPr sz="3000" b="1">
+              <a:rPr sz="2800" b="1">
                 <a:solidFill>
                   <a:srgbClr val="154E37"/>
                 </a:solidFill>
               </a:rPr>
-              <a:t>Method 2/2 - Static ROIs + IoU</a:t>
-            </a:r>
-          </a:p>
-        </p:txBody>
-      </p:sp>
-      <p:sp>
-        <p:nvSpPr>
-          <p:cNvPr id="3" name="Content Placeholder 2"/>
-          <p:cNvSpPr>
-            <a:spLocks noGrp="1"/>
-          </p:cNvSpPr>
-          <p:nvPr>
-            <p:ph idx="1"/>
-          </p:nvPr>
-        </p:nvSpPr>
-        <p:spPr/>
-        <p:txBody>
-          <a:bodyPr wrap="square"/>
-          <a:lstStyle/>
-          <a:p>
-            <a:r>
-              <a:rPr sz="2000">
+              <a:t>How the model works  |  Frame -&gt; YOLOv8 -&gt; ROIs -&gt; IoU &gt; 0.5</a:t>
+            </a:r>
+          </a:p>
+        </p:txBody>
+      </p:sp>
+      <p:pic>
+        <p:nvPicPr>
+          <p:cNvPr id="3" name="Picture 2" descr="pipeline_visual.png"/>
+          <p:cNvPicPr>
+            <a:picLocks noChangeAspect="1"/>
+          </p:cNvPicPr>
+          <p:nvPr/>
+        </p:nvPicPr>
+        <p:blipFill>
+          <a:blip r:embed="rId2"/>
+          <a:stretch>
+            <a:fillRect/>
+          </a:stretch>
+        </p:blipFill>
+        <p:spPr>
+          <a:xfrm>
+            <a:off x="914400" y="1280160"/>
+            <a:ext cx="10058400" cy="6328881"/>
+          </a:xfrm>
+          <a:prstGeom prst="rect">
+            <a:avLst/>
+          </a:prstGeom>
+        </p:spPr>
+      </p:pic>
+      <p:sp>
+        <p:nvSpPr>
+          <p:cNvPr id="4" name="TextBox 3"/>
+          <p:cNvSpPr txBox="1"/>
+          <p:nvPr/>
+        </p:nvSpPr>
+        <p:spPr>
+          <a:xfrm>
+            <a:off x="640080" y="5760720"/>
+            <a:ext cx="10972800" cy="914400"/>
+          </a:xfrm>
+          <a:prstGeom prst="rect">
+            <a:avLst/>
+          </a:prstGeom>
+          <a:noFill/>
+        </p:spPr>
+        <p:txBody>
+          <a:bodyPr wrap="square">
+            <a:spAutoFit/>
+          </a:bodyPr>
+          <a:lstStyle/>
+          <a:p>
+            <a:r>
+              <a:rPr sz="1400">
                 <a:solidFill>
                   <a:srgbClr val="222222"/>
                 </a:solidFill>
               </a:rPr>
-              <a:t>One-time setup: click 2 corners per spot (roi_picker.py).</a:t>
-            </a:r>
-          </a:p>
-          <a:p>
-            <a:pPr/>
-            <a:r>
-              <a:rPr sz="2000">
-                <a:solidFill>
-                  <a:srgbClr val="222222"/>
-                </a:solidFill>
-              </a:rPr>
-              <a:t>Stored as JSON of axis-aligned boxes; reloaded at runtime.</a:t>
-            </a:r>
-          </a:p>
-          <a:p>
-            <a:pPr/>
-            <a:r>
-              <a:rPr sz="2000">
-                <a:solidFill>
-                  <a:srgbClr val="222222"/>
-                </a:solidFill>
-              </a:rPr>
-              <a:t>Per frame, per spot: IoU(spot, vehicle).</a:t>
-            </a:r>
-          </a:p>
-          <a:p>
-            <a:pPr/>
-            <a:r>
-              <a:rPr sz="2000">
-                <a:solidFill>
-                  <a:srgbClr val="222222"/>
-                </a:solidFill>
-              </a:rPr>
-              <a:t>Decision: Occupied iff max IoU &gt; 0.5 (PASCAL VOC convention).</a:t>
-            </a:r>
-          </a:p>
-          <a:p>
-            <a:pPr/>
-            <a:r>
-              <a:rPr sz="2000">
-                <a:solidFill>
-                  <a:srgbClr val="222222"/>
-                </a:solidFill>
-              </a:rPr>
-              <a:t>Stateless, O(N x M) per frame, negligible vs detector cost.</a:t>
+              <a:t>1) Detector: YOLOv8n (Ultralytics, 6 MB), COCO weights, filtered to {car, truck, bus, motorcycle}.  2) Registration: click 2 corners per spot once -&gt; rois.json.  3) Decision: per spot, if max IoU with any vehicle &gt; 0.5 -&gt; Occupied (red), else Open (green). No training.</a:t>
             </a:r>
           </a:p>
         </p:txBody>
@@ -4597,71 +5014,126 @@
           <a:lstStyle/>
           <a:p>
             <a:r>
-              <a:rPr sz="3000" b="1">
+              <a:rPr sz="2800" b="1">
                 <a:solidFill>
                   <a:srgbClr val="154E37"/>
                 </a:solidFill>
               </a:rPr>
-              <a:t>Data &amp; Setup</a:t>
-            </a:r>
-          </a:p>
-        </p:txBody>
-      </p:sp>
-      <p:sp>
-        <p:nvSpPr>
-          <p:cNvPr id="3" name="Content Placeholder 2"/>
-          <p:cNvSpPr>
-            <a:spLocks noGrp="1"/>
-          </p:cNvSpPr>
-          <p:nvPr>
-            <p:ph idx="1"/>
-          </p:nvPr>
-        </p:nvSpPr>
-        <p:spPr/>
-        <p:txBody>
-          <a:bodyPr wrap="square"/>
-          <a:lstStyle/>
-          <a:p>
-            <a:r>
-              <a:rPr sz="2000">
-                <a:solidFill>
-                  <a:srgbClr val="222222"/>
+              <a:t>Setup: register once, label ground truth once</a:t>
+            </a:r>
+          </a:p>
+        </p:txBody>
+      </p:sp>
+      <p:pic>
+        <p:nvPicPr>
+          <p:cNvPr id="3" name="Picture 2" descr="roi_labeling.png"/>
+          <p:cNvPicPr>
+            <a:picLocks noChangeAspect="1"/>
+          </p:cNvPicPr>
+          <p:nvPr/>
+        </p:nvPicPr>
+        <p:blipFill>
+          <a:blip r:embed="rId2"/>
+          <a:stretch>
+            <a:fillRect/>
+          </a:stretch>
+        </p:blipFill>
+        <p:spPr>
+          <a:xfrm>
+            <a:off x="365760" y="1371600"/>
+            <a:ext cx="5486400" cy="3001992"/>
+          </a:xfrm>
+          <a:prstGeom prst="rect">
+            <a:avLst/>
+          </a:prstGeom>
+        </p:spPr>
+      </p:pic>
+      <p:pic>
+        <p:nvPicPr>
+          <p:cNvPr id="4" name="Picture 3" descr="gt_labeling.png"/>
+          <p:cNvPicPr>
+            <a:picLocks noChangeAspect="1"/>
+          </p:cNvPicPr>
+          <p:nvPr/>
+        </p:nvPicPr>
+        <p:blipFill>
+          <a:blip r:embed="rId3"/>
+          <a:stretch>
+            <a:fillRect/>
+          </a:stretch>
+        </p:blipFill>
+        <p:spPr>
+          <a:xfrm>
+            <a:off x="6309360" y="1371600"/>
+            <a:ext cx="5486400" cy="3001992"/>
+          </a:xfrm>
+          <a:prstGeom prst="rect">
+            <a:avLst/>
+          </a:prstGeom>
+        </p:spPr>
+      </p:pic>
+      <p:sp>
+        <p:nvSpPr>
+          <p:cNvPr id="5" name="TextBox 4"/>
+          <p:cNvSpPr txBox="1"/>
+          <p:nvPr/>
+        </p:nvSpPr>
+        <p:spPr>
+          <a:xfrm>
+            <a:off x="365760" y="5029200"/>
+            <a:ext cx="5486400" cy="548640"/>
+          </a:xfrm>
+          <a:prstGeom prst="rect">
+            <a:avLst/>
+          </a:prstGeom>
+          <a:noFill/>
+        </p:spPr>
+        <p:txBody>
+          <a:bodyPr wrap="none">
+            <a:spAutoFit/>
+          </a:bodyPr>
+          <a:lstStyle/>
+          <a:p>
+            <a:r>
+              <a:rPr sz="1400" i="1">
+                <a:solidFill>
+                  <a:srgbClr val="666666"/>
                 </a:solidFill>
               </a:rPr>
-              <a:t>Custom UTD clip: 41 s @ 848x464 / 30 fps, upper-floor walkway, ~30 deg down.</a:t>
-            </a:r>
-          </a:p>
-          <a:p>
-            <a:pPr/>
-            <a:r>
-              <a:rPr sz="2000">
-                <a:solidFill>
-                  <a:srgbClr val="222222"/>
+              <a:t>1. roi_picker.py - click two corners per spot, save rois.json</a:t>
+            </a:r>
+          </a:p>
+        </p:txBody>
+      </p:sp>
+      <p:sp>
+        <p:nvSpPr>
+          <p:cNvPr id="6" name="TextBox 5"/>
+          <p:cNvSpPr txBox="1"/>
+          <p:nvPr/>
+        </p:nvSpPr>
+        <p:spPr>
+          <a:xfrm>
+            <a:off x="6309360" y="5029200"/>
+            <a:ext cx="5486400" cy="548640"/>
+          </a:xfrm>
+          <a:prstGeom prst="rect">
+            <a:avLst/>
+          </a:prstGeom>
+          <a:noFill/>
+        </p:spPr>
+        <p:txBody>
+          <a:bodyPr wrap="none">
+            <a:spAutoFit/>
+          </a:bodyPr>
+          <a:lstStyle/>
+          <a:p>
+            <a:r>
+              <a:rPr sz="1400" i="1">
+                <a:solidFill>
+                  <a:srgbClr val="666666"/>
                 </a:solidFill>
               </a:rPr>
-              <a:t>Camera fully static (start frame = end frame).</a:t>
-            </a:r>
-          </a:p>
-          <a:p>
-            <a:pPr/>
-            <a:r>
-              <a:rPr sz="2000">
-                <a:solidFill>
-                  <a:srgbClr val="222222"/>
-                </a:solidFill>
-              </a:rPr>
-              <a:t>17 parking-spot ROIs covering 3 rows, manually registered with roi_picker.py.</a:t>
-            </a:r>
-          </a:p>
-          <a:p>
-            <a:pPr/>
-            <a:r>
-              <a:rPr sz="2000">
-                <a:solidFill>
-                  <a:srgbClr val="222222"/>
-                </a:solidFill>
-              </a:rPr>
-              <a:t>Ground truth: 5 frames x 17 spots = 85 manual labels.</a:t>
+              <a:t>2. label_gt.py - press o (occupied) / e (empty) per spot, 5 frames</a:t>
             </a:r>
           </a:p>
         </p:txBody>
@@ -4700,426 +5172,40 @@
           <a:lstStyle/>
           <a:p>
             <a:r>
-              <a:rPr sz="3000" b="1">
+              <a:rPr sz="2800" b="1">
                 <a:solidFill>
                   <a:srgbClr val="154E37"/>
                 </a:solidFill>
               </a:rPr>
-              <a:t>Results</a:t>
-            </a:r>
-          </a:p>
-        </p:txBody>
-      </p:sp>
-      <p:graphicFrame>
-        <p:nvGraphicFramePr>
-          <p:cNvPr id="3" name="Table 2"/>
-          <p:cNvGraphicFramePr>
-            <a:graphicFrameLocks noGrp="1"/>
-          </p:cNvGraphicFramePr>
+              <a:t>Results on the live UTD recording</a:t>
+            </a:r>
+          </a:p>
+        </p:txBody>
+      </p:sp>
+      <p:pic>
+        <p:nvPicPr>
+          <p:cNvPr id="3" name="Picture 2" descr="results_chart.png"/>
+          <p:cNvPicPr>
+            <a:picLocks noChangeAspect="1"/>
+          </p:cNvPicPr>
           <p:nvPr/>
-        </p:nvGraphicFramePr>
-        <p:xfrm>
-          <a:off x="640080" y="1463040"/>
-          <a:ext cx="7772400" cy="3657600"/>
-        </p:xfrm>
-        <a:graphic>
-          <a:graphicData uri="http://schemas.openxmlformats.org/drawingml/2006/table">
-            <a:tbl>
-              <a:tblPr firstRow="1" bandRow="1">
-                <a:tableStyleId>{5C22544A-7EE6-4342-B048-85BDC9FD1C3A}</a:tableStyleId>
-              </a:tblPr>
-              <a:tblGrid>
-                <a:gridCol w="2590800"/>
-                <a:gridCol w="2590800"/>
-                <a:gridCol w="2590800"/>
-              </a:tblGrid>
-              <a:tr h="522514">
-                <a:tc>
-                  <a:txBody>
-                    <a:bodyPr/>
-                    <a:lstStyle/>
-                    <a:p>
-                      <a:r>
-                        <a:rPr b="1" sz="1800">
-                          <a:solidFill>
-                            <a:srgbClr val="FFFFFF"/>
-                          </a:solidFill>
-                        </a:rPr>
-                        <a:t>Metric</a:t>
-                      </a:r>
-                    </a:p>
-                  </a:txBody>
-                  <a:tcPr>
-                    <a:solidFill>
-                      <a:srgbClr val="154E37"/>
-                    </a:solidFill>
-                  </a:tcPr>
-                </a:tc>
-                <a:tc>
-                  <a:txBody>
-                    <a:bodyPr/>
-                    <a:lstStyle/>
-                    <a:p>
-                      <a:r>
-                        <a:rPr b="1" sz="1800">
-                          <a:solidFill>
-                            <a:srgbClr val="FFFFFF"/>
-                          </a:solidFill>
-                        </a:rPr>
-                        <a:t>Synthetic 90-frame</a:t>
-                      </a:r>
-                    </a:p>
-                  </a:txBody>
-                  <a:tcPr>
-                    <a:solidFill>
-                      <a:srgbClr val="154E37"/>
-                    </a:solidFill>
-                  </a:tcPr>
-                </a:tc>
-                <a:tc>
-                  <a:txBody>
-                    <a:bodyPr/>
-                    <a:lstStyle/>
-                    <a:p>
-                      <a:r>
-                        <a:rPr b="1" sz="1800">
-                          <a:solidFill>
-                            <a:srgbClr val="FFFFFF"/>
-                          </a:solidFill>
-                        </a:rPr>
-                        <a:t>UTD live</a:t>
-                      </a:r>
-                    </a:p>
-                  </a:txBody>
-                  <a:tcPr>
-                    <a:solidFill>
-                      <a:srgbClr val="154E37"/>
-                    </a:solidFill>
-                  </a:tcPr>
-                </a:tc>
-              </a:tr>
-              <a:tr h="522514">
-                <a:tc>
-                  <a:txBody>
-                    <a:bodyPr/>
-                    <a:lstStyle/>
-                    <a:p>
-                      <a:r>
-                        <a:rPr sz="1600">
-                          <a:solidFill>
-                            <a:srgbClr val="222222"/>
-                          </a:solidFill>
-                        </a:rPr>
-                        <a:t>Occupancy Accuracy</a:t>
-                      </a:r>
-                    </a:p>
-                  </a:txBody>
-                  <a:tcPr/>
-                </a:tc>
-                <a:tc>
-                  <a:txBody>
-                    <a:bodyPr/>
-                    <a:lstStyle/>
-                    <a:p>
-                      <a:r>
-                        <a:rPr sz="1600">
-                          <a:solidFill>
-                            <a:srgbClr val="222222"/>
-                          </a:solidFill>
-                        </a:rPr>
-                        <a:t>79.6 %</a:t>
-                      </a:r>
-                    </a:p>
-                  </a:txBody>
-                  <a:tcPr/>
-                </a:tc>
-                <a:tc>
-                  <a:txBody>
-                    <a:bodyPr/>
-                    <a:lstStyle/>
-                    <a:p>
-                      <a:r>
-                        <a:rPr sz="1600">
-                          <a:solidFill>
-                            <a:srgbClr val="222222"/>
-                          </a:solidFill>
-                        </a:rPr>
-                        <a:t>97.6 %</a:t>
-                      </a:r>
-                    </a:p>
-                  </a:txBody>
-                  <a:tcPr/>
-                </a:tc>
-              </a:tr>
-              <a:tr h="522514">
-                <a:tc>
-                  <a:txBody>
-                    <a:bodyPr/>
-                    <a:lstStyle/>
-                    <a:p>
-                      <a:r>
-                        <a:rPr sz="1600">
-                          <a:solidFill>
-                            <a:srgbClr val="222222"/>
-                          </a:solidFill>
-                        </a:rPr>
-                        <a:t>Precision (Occupied)</a:t>
-                      </a:r>
-                    </a:p>
-                  </a:txBody>
-                  <a:tcPr/>
-                </a:tc>
-                <a:tc>
-                  <a:txBody>
-                    <a:bodyPr/>
-                    <a:lstStyle/>
-                    <a:p>
-                      <a:r>
-                        <a:rPr sz="1600">
-                          <a:solidFill>
-                            <a:srgbClr val="222222"/>
-                          </a:solidFill>
-                        </a:rPr>
-                        <a:t>100.0 %</a:t>
-                      </a:r>
-                    </a:p>
-                  </a:txBody>
-                  <a:tcPr/>
-                </a:tc>
-                <a:tc>
-                  <a:txBody>
-                    <a:bodyPr/>
-                    <a:lstStyle/>
-                    <a:p>
-                      <a:r>
-                        <a:rPr sz="1600">
-                          <a:solidFill>
-                            <a:srgbClr val="222222"/>
-                          </a:solidFill>
-                        </a:rPr>
-                        <a:t>98.2 %</a:t>
-                      </a:r>
-                    </a:p>
-                  </a:txBody>
-                  <a:tcPr/>
-                </a:tc>
-              </a:tr>
-              <a:tr h="522514">
-                <a:tc>
-                  <a:txBody>
-                    <a:bodyPr/>
-                    <a:lstStyle/>
-                    <a:p>
-                      <a:r>
-                        <a:rPr sz="1600">
-                          <a:solidFill>
-                            <a:srgbClr val="222222"/>
-                          </a:solidFill>
-                        </a:rPr>
-                        <a:t>Recall (Occupied)</a:t>
-                      </a:r>
-                    </a:p>
-                  </a:txBody>
-                  <a:tcPr/>
-                </a:tc>
-                <a:tc>
-                  <a:txBody>
-                    <a:bodyPr/>
-                    <a:lstStyle/>
-                    <a:p>
-                      <a:r>
-                        <a:rPr sz="1600">
-                          <a:solidFill>
-                            <a:srgbClr val="222222"/>
-                          </a:solidFill>
-                        </a:rPr>
-                        <a:t>74.2 %</a:t>
-                      </a:r>
-                    </a:p>
-                  </a:txBody>
-                  <a:tcPr/>
-                </a:tc>
-                <a:tc>
-                  <a:txBody>
-                    <a:bodyPr/>
-                    <a:lstStyle/>
-                    <a:p>
-                      <a:r>
-                        <a:rPr sz="1600">
-                          <a:solidFill>
-                            <a:srgbClr val="222222"/>
-                          </a:solidFill>
-                        </a:rPr>
-                        <a:t>98.2 %</a:t>
-                      </a:r>
-                    </a:p>
-                  </a:txBody>
-                  <a:tcPr/>
-                </a:tc>
-              </a:tr>
-              <a:tr h="522514">
-                <a:tc>
-                  <a:txBody>
-                    <a:bodyPr/>
-                    <a:lstStyle/>
-                    <a:p>
-                      <a:r>
-                        <a:rPr sz="1600">
-                          <a:solidFill>
-                            <a:srgbClr val="222222"/>
-                          </a:solidFill>
-                        </a:rPr>
-                        <a:t>F1 (Occupied)</a:t>
-                      </a:r>
-                    </a:p>
-                  </a:txBody>
-                  <a:tcPr/>
-                </a:tc>
-                <a:tc>
-                  <a:txBody>
-                    <a:bodyPr/>
-                    <a:lstStyle/>
-                    <a:p>
-                      <a:r>
-                        <a:rPr sz="1600">
-                          <a:solidFill>
-                            <a:srgbClr val="222222"/>
-                          </a:solidFill>
-                        </a:rPr>
-                        <a:t>85.2 %</a:t>
-                      </a:r>
-                    </a:p>
-                  </a:txBody>
-                  <a:tcPr/>
-                </a:tc>
-                <a:tc>
-                  <a:txBody>
-                    <a:bodyPr/>
-                    <a:lstStyle/>
-                    <a:p>
-                      <a:r>
-                        <a:rPr sz="1600">
-                          <a:solidFill>
-                            <a:srgbClr val="222222"/>
-                          </a:solidFill>
-                        </a:rPr>
-                        <a:t>98.2 %</a:t>
-                      </a:r>
-                    </a:p>
-                  </a:txBody>
-                  <a:tcPr/>
-                </a:tc>
-              </a:tr>
-              <a:tr h="522514">
-                <a:tc>
-                  <a:txBody>
-                    <a:bodyPr/>
-                    <a:lstStyle/>
-                    <a:p>
-                      <a:r>
-                        <a:rPr sz="1600">
-                          <a:solidFill>
-                            <a:srgbClr val="222222"/>
-                          </a:solidFill>
-                        </a:rPr>
-                        <a:t>Inference FPS (CPU)</a:t>
-                      </a:r>
-                    </a:p>
-                  </a:txBody>
-                  <a:tcPr/>
-                </a:tc>
-                <a:tc>
-                  <a:txBody>
-                    <a:bodyPr/>
-                    <a:lstStyle/>
-                    <a:p>
-                      <a:r>
-                        <a:rPr sz="1600">
-                          <a:solidFill>
-                            <a:srgbClr val="222222"/>
-                          </a:solidFill>
-                        </a:rPr>
-                        <a:t>5.9</a:t>
-                      </a:r>
-                    </a:p>
-                  </a:txBody>
-                  <a:tcPr/>
-                </a:tc>
-                <a:tc>
-                  <a:txBody>
-                    <a:bodyPr/>
-                    <a:lstStyle/>
-                    <a:p>
-                      <a:r>
-                        <a:rPr sz="1600">
-                          <a:solidFill>
-                            <a:srgbClr val="222222"/>
-                          </a:solidFill>
-                        </a:rPr>
-                        <a:t>17.3</a:t>
-                      </a:r>
-                    </a:p>
-                  </a:txBody>
-                  <a:tcPr/>
-                </a:tc>
-              </a:tr>
-              <a:tr h="522516">
-                <a:tc>
-                  <a:txBody>
-                    <a:bodyPr/>
-                    <a:lstStyle/>
-                    <a:p>
-                      <a:r>
-                        <a:rPr sz="1600">
-                          <a:solidFill>
-                            <a:srgbClr val="222222"/>
-                          </a:solidFill>
-                        </a:rPr>
-                        <a:t>End-to-end FPS</a:t>
-                      </a:r>
-                    </a:p>
-                  </a:txBody>
-                  <a:tcPr/>
-                </a:tc>
-                <a:tc>
-                  <a:txBody>
-                    <a:bodyPr/>
-                    <a:lstStyle/>
-                    <a:p>
-                      <a:r>
-                        <a:rPr sz="1600">
-                          <a:solidFill>
-                            <a:srgbClr val="222222"/>
-                          </a:solidFill>
-                        </a:rPr>
-                        <a:t>4.8</a:t>
-                      </a:r>
-                    </a:p>
-                  </a:txBody>
-                  <a:tcPr/>
-                </a:tc>
-                <a:tc>
-                  <a:txBody>
-                    <a:bodyPr/>
-                    <a:lstStyle/>
-                    <a:p>
-                      <a:r>
-                        <a:rPr sz="1600">
-                          <a:solidFill>
-                            <a:srgbClr val="222222"/>
-                          </a:solidFill>
-                        </a:rPr>
-                        <a:t>15.7</a:t>
-                      </a:r>
-                    </a:p>
-                  </a:txBody>
-                  <a:tcPr/>
-                </a:tc>
-              </a:tr>
-            </a:tbl>
-          </a:graphicData>
-        </a:graphic>
-      </p:graphicFrame>
+        </p:nvPicPr>
+        <p:blipFill>
+          <a:blip r:embed="rId2"/>
+          <a:stretch>
+            <a:fillRect/>
+          </a:stretch>
+        </p:blipFill>
+        <p:spPr>
+          <a:xfrm>
+            <a:off x="274320" y="1280160"/>
+            <a:ext cx="7772400" cy="4533900"/>
+          </a:xfrm>
+          <a:prstGeom prst="rect">
+            <a:avLst/>
+          </a:prstGeom>
+        </p:spPr>
+      </p:pic>
       <p:sp>
         <p:nvSpPr>
           <p:cNvPr id="4" name="TextBox 3"/>
@@ -5128,8 +5214,8 @@
         </p:nvSpPr>
         <p:spPr>
           <a:xfrm>
-            <a:off x="640080" y="5303520"/>
-            <a:ext cx="7772400" cy="914400"/>
+            <a:off x="8229600" y="1280160"/>
+            <a:ext cx="3657600" cy="5029200"/>
           </a:xfrm>
           <a:prstGeom prst="rect">
             <a:avLst/>
@@ -5137,18 +5223,158 @@
           <a:noFill/>
         </p:spPr>
         <p:txBody>
-          <a:bodyPr wrap="none">
+          <a:bodyPr wrap="square">
             <a:spAutoFit/>
           </a:bodyPr>
           <a:lstStyle/>
           <a:p>
             <a:r>
-              <a:rPr i="1" sz="1400">
+              <a:rPr b="1" sz="1600">
+                <a:solidFill>
+                  <a:srgbClr val="154E37"/>
+                </a:solidFill>
+              </a:rPr>
+              <a:t>Headline numbers (UTD live)</a:t>
+            </a:r>
+          </a:p>
+          <a:p>
+            <a:r>
+              <a:rPr sz="1300">
                 <a:solidFill>
                   <a:srgbClr val="666666"/>
                 </a:solidFill>
               </a:rPr>
-              <a:t>Embed demo_video.mp4 on the next slide / on click.</a:t>
+              <a:t>Accuracy</a:t>
+            </a:r>
+          </a:p>
+          <a:p>
+            <a:r>
+              <a:rPr sz="2000" b="1">
+                <a:solidFill>
+                  <a:srgbClr val="222222"/>
+                </a:solidFill>
+              </a:rPr>
+              <a:t>97.6 %</a:t>
+            </a:r>
+          </a:p>
+          <a:p>
+            <a:r>
+              <a:rPr sz="1300">
+                <a:solidFill>
+                  <a:srgbClr val="666666"/>
+                </a:solidFill>
+              </a:rPr>
+              <a:t>Precision</a:t>
+            </a:r>
+          </a:p>
+          <a:p>
+            <a:r>
+              <a:rPr sz="2000" b="1">
+                <a:solidFill>
+                  <a:srgbClr val="222222"/>
+                </a:solidFill>
+              </a:rPr>
+              <a:t>98.2 %</a:t>
+            </a:r>
+          </a:p>
+          <a:p>
+            <a:r>
+              <a:rPr sz="1300">
+                <a:solidFill>
+                  <a:srgbClr val="666666"/>
+                </a:solidFill>
+              </a:rPr>
+              <a:t>Recall</a:t>
+            </a:r>
+          </a:p>
+          <a:p>
+            <a:r>
+              <a:rPr sz="2000" b="1">
+                <a:solidFill>
+                  <a:srgbClr val="222222"/>
+                </a:solidFill>
+              </a:rPr>
+              <a:t>98.2 %</a:t>
+            </a:r>
+          </a:p>
+          <a:p>
+            <a:r>
+              <a:rPr sz="1300">
+                <a:solidFill>
+                  <a:srgbClr val="666666"/>
+                </a:solidFill>
+              </a:rPr>
+              <a:t>F1</a:t>
+            </a:r>
+          </a:p>
+          <a:p>
+            <a:r>
+              <a:rPr sz="2000" b="1">
+                <a:solidFill>
+                  <a:srgbClr val="222222"/>
+                </a:solidFill>
+              </a:rPr>
+              <a:t>98.2 %</a:t>
+            </a:r>
+          </a:p>
+          <a:p>
+            <a:r>
+              <a:rPr sz="1300">
+                <a:solidFill>
+                  <a:srgbClr val="666666"/>
+                </a:solidFill>
+              </a:rPr>
+              <a:t>Inference (CPU, model only)</a:t>
+            </a:r>
+          </a:p>
+          <a:p>
+            <a:r>
+              <a:rPr sz="2000" b="1">
+                <a:solidFill>
+                  <a:srgbClr val="222222"/>
+                </a:solidFill>
+              </a:rPr>
+              <a:t>17.3 FPS</a:t>
+            </a:r>
+          </a:p>
+          <a:p>
+            <a:r>
+              <a:rPr sz="1300">
+                <a:solidFill>
+                  <a:srgbClr val="666666"/>
+                </a:solidFill>
+              </a:rPr>
+              <a:t>End-to-end FPS</a:t>
+            </a:r>
+          </a:p>
+          <a:p>
+            <a:r>
+              <a:rPr sz="2000" b="1">
+                <a:solidFill>
+                  <a:srgbClr val="222222"/>
+                </a:solidFill>
+              </a:rPr>
+              <a:t>15.7 FPS</a:t>
+            </a:r>
+          </a:p>
+          <a:p>
+            <a:r>
+              <a:rPr sz="1300">
+                <a:solidFill>
+                  <a:srgbClr val="666666"/>
+                </a:solidFill>
+              </a:rPr>
+              <a:t>Errors</a:t>
+            </a:r>
+          </a:p>
+          <a:p>
+            <a:r>
+              <a:rPr sz="2000" b="1">
+                <a:solidFill>
+                  <a:srgbClr val="222222"/>
+                </a:solidFill>
+              </a:rPr>
+              <a:t>2 / 85</a:t>
             </a:r>
           </a:p>
         </p:txBody>
@@ -5192,7 +5418,7 @@
                   <a:srgbClr val="154E37"/>
                 </a:solidFill>
               </a:rPr>
-              <a:t>Live Demo</a:t>
+              <a:t>Live demo</a:t>
             </a:r>
           </a:p>
         </p:txBody>
@@ -5218,7 +5444,7 @@
                   <a:srgbClr val="222222"/>
                 </a:solidFill>
               </a:rPr>
-              <a:t>Green = Empty,  Red = Occupied.</a:t>
+              <a:t>Red = Occupied,  Green = Open.</a:t>
             </a:r>
           </a:p>
           <a:p>
@@ -5229,7 +5455,7 @@
                   <a:srgbClr val="222222"/>
                 </a:solidFill>
               </a:rPr>
-              <a:t>HUD: live FPS and Occupied/Total counter.</a:t>
+              <a:t>HUD: live FPS  |  Occupied count (red)  |  Open count (green).</a:t>
             </a:r>
           </a:p>
           <a:p>
@@ -5240,7 +5466,18 @@
                   <a:srgbClr val="222222"/>
                 </a:solidFill>
               </a:rPr>
-              <a:t>Watch one spot flip as a car backs in.</a:t>
+              <a:t>Watch a spot flip as a car arrives or leaves.</a:t>
+            </a:r>
+          </a:p>
+          <a:p>
+            <a:pPr/>
+            <a:r>
+              <a:rPr sz="2000">
+                <a:solidFill>
+                  <a:srgbClr val="222222"/>
+                </a:solidFill>
+              </a:rPr>
+              <a:t>[Insert results/utd_demo.mp4 here in PowerPoint.]</a:t>
             </a:r>
           </a:p>
         </p:txBody>
@@ -5279,71 +5516,69 @@
           <a:lstStyle/>
           <a:p>
             <a:r>
-              <a:rPr sz="3000" b="1">
+              <a:rPr sz="2800" b="1">
                 <a:solidFill>
                   <a:srgbClr val="154E37"/>
                 </a:solidFill>
               </a:rPr>
-              <a:t>Failure Analysis</a:t>
-            </a:r>
-          </a:p>
-        </p:txBody>
-      </p:sp>
-      <p:sp>
-        <p:nvSpPr>
-          <p:cNvPr id="3" name="Content Placeholder 2"/>
-          <p:cNvSpPr>
-            <a:spLocks noGrp="1"/>
-          </p:cNvSpPr>
-          <p:nvPr>
-            <p:ph idx="1"/>
-          </p:nvPr>
-        </p:nvSpPr>
-        <p:spPr/>
-        <p:txBody>
-          <a:bodyPr wrap="square"/>
-          <a:lstStyle/>
-          <a:p>
-            <a:r>
-              <a:rPr sz="2000">
+              <a:t>From 64% recall to 98% - by REDRAWING rectangles, not retraining</a:t>
+            </a:r>
+          </a:p>
+        </p:txBody>
+      </p:sp>
+      <p:pic>
+        <p:nvPicPr>
+          <p:cNvPr id="3" name="Picture 2" descr="precision_recall.png"/>
+          <p:cNvPicPr>
+            <a:picLocks noChangeAspect="1"/>
+          </p:cNvPicPr>
+          <p:nvPr/>
+        </p:nvPicPr>
+        <p:blipFill>
+          <a:blip r:embed="rId2"/>
+          <a:stretch>
+            <a:fillRect/>
+          </a:stretch>
+        </p:blipFill>
+        <p:spPr>
+          <a:xfrm>
+            <a:off x="914400" y="1280160"/>
+            <a:ext cx="10058400" cy="5669280"/>
+          </a:xfrm>
+          <a:prstGeom prst="rect">
+            <a:avLst/>
+          </a:prstGeom>
+        </p:spPr>
+      </p:pic>
+      <p:sp>
+        <p:nvSpPr>
+          <p:cNvPr id="4" name="TextBox 3"/>
+          <p:cNvSpPr txBox="1"/>
+          <p:nvPr/>
+        </p:nvSpPr>
+        <p:spPr>
+          <a:xfrm>
+            <a:off x="640080" y="5760720"/>
+            <a:ext cx="10972800" cy="914400"/>
+          </a:xfrm>
+          <a:prstGeom prst="rect">
+            <a:avLst/>
+          </a:prstGeom>
+          <a:noFill/>
+        </p:spPr>
+        <p:txBody>
+          <a:bodyPr wrap="square">
+            <a:spAutoFit/>
+          </a:bodyPr>
+          <a:lstStyle/>
+          <a:p>
+            <a:r>
+              <a:rPr sz="1400">
                 <a:solidFill>
                   <a:srgbClr val="222222"/>
                 </a:solidFill>
               </a:rPr>
-              <a:t>ROI sizing matters: tight ROIs -&gt; low recall (64%); proper ROIs -&gt; 98% recall.</a:t>
-            </a:r>
-          </a:p>
-          <a:p>
-            <a:pPr/>
-            <a:r>
-              <a:rPr sz="2000">
-                <a:solidFill>
-                  <a:srgbClr val="222222"/>
-                </a:solidFill>
-              </a:rPr>
-              <a:t>Boundary-straddling vehicles cause both an FP and an FN on adjacent spots.</a:t>
-            </a:r>
-          </a:p>
-          <a:p>
-            <a:pPr/>
-            <a:r>
-              <a:rPr sz="2000">
-                <a:solidFill>
-                  <a:srgbClr val="222222"/>
-                </a:solidFill>
-              </a:rPr>
-              <a:t>Top-down (~90 deg) views: COCO YOLO mis-classifies cars as appliances.</a:t>
-            </a:r>
-          </a:p>
-          <a:p>
-            <a:pPr/>
-            <a:r>
-              <a:rPr sz="2000">
-                <a:solidFill>
-                  <a:srgbClr val="222222"/>
-                </a:solidFill>
-              </a:rPr>
-              <a:t>Camera drift: small physical shift misaligns every ROI.</a:t>
+              <a:t>Round 1 (tight slivers along painted lines): 63.8% recall - ROIs traced visible asphalt, missed the actual car bodies.  Round 2 (car-sized boxes): 79.7%.  Round 3 (enlarged foreground rectangles to match perspective): 98.2%. In a static-ROI system, the ROI IS the model.</a:t>
             </a:r>
           </a:p>
         </p:txBody>
@@ -5387,7 +5622,7 @@
                   <a:srgbClr val="154E37"/>
                 </a:solidFill>
               </a:rPr>
-              <a:t>Conclusion &amp; Next Steps</a:t>
+              <a:t>Failure analysis (and how to fix each)</a:t>
             </a:r>
           </a:p>
         </p:txBody>
@@ -5413,7 +5648,7 @@
                   <a:srgbClr val="222222"/>
                 </a:solidFill>
               </a:rPr>
-              <a:t>Real-time per-spot occupancy with NO per-camera training.</a:t>
+              <a:t>Top-down (~90 deg) cameras: COCO YOLO mis-classifies cars as ovens / microwaves -&gt; mount cameras at 30-60 deg.</a:t>
             </a:r>
           </a:p>
           <a:p>
@@ -5424,7 +5659,7 @@
                   <a:srgbClr val="222222"/>
                 </a:solidFill>
               </a:rPr>
-              <a:t>Next: polygonal ROIs, periodic re-registration via line fiducials.</a:t>
+              <a:t>Heavy occlusion in back rows: a foreground SUV can hide a back-row spot -&gt; recover with a second camera or polygonal ROIs.</a:t>
             </a:r>
           </a:p>
           <a:p>
@@ -5435,7 +5670,7 @@
                   <a:srgbClr val="222222"/>
                 </a:solidFill>
               </a:rPr>
-              <a:t>Multi-camera fusion to recover occluded back rows.</a:t>
+              <a:t>Boundary-straddling vehicles: 1 FP + 1 FN on adjacent spots, a case where humans also disagree.</a:t>
             </a:r>
           </a:p>
           <a:p>
@@ -5446,18 +5681,7 @@
                   <a:srgbClr val="222222"/>
                 </a:solidFill>
               </a:rPr>
-              <a:t>Code, report, and demo video are in the submission zip.</a:t>
-            </a:r>
-          </a:p>
-          <a:p>
-            <a:pPr/>
-            <a:r>
-              <a:rPr sz="2000">
-                <a:solidFill>
-                  <a:srgbClr val="222222"/>
-                </a:solidFill>
-              </a:rPr>
-              <a:t>Thank you - questions?</a:t>
+              <a:t>Camera physical drift: every ROI shifts together -&gt; periodic re-registration against painted-line fiducials.</a:t>
             </a:r>
           </a:p>
         </p:txBody>

</xml_diff>